<commit_message>
Phases 121, 122, 128: Description intel, POC extraction, federal identifier extraction
Phase 121 (IN PROGRESS): AI analysis of opportunity descriptions
- New analyze_descriptions CLI command (extract description-ai)
- Combined description + attachment text for AI context
- API fix for description-only intel display
- Opus model option removed (ENUM prerequisite)

Phase 122 (COMPLETE): Point of contact extraction
- POC data from raw JSON via backfill pocs CLI command
- C# API returns POCs in opportunity detail DTO
- UI card with name, type, title, email, phone, fax

Phase 128 (IN PROGRESS): Federal identifier extraction
- Regex extraction for 10 identifier types (PIID, UEI, CAGE, etc.)
- document_identifier_ref table + SQL views for cross-referencing
- Dual search (dashed + dashless) for cross-ref matching
- New API endpoint GET /api/opportunities/{noticeId}/identifier-refs
- Phase 132 planned for full dash normalization

Also includes: Phase 114 doc moved to completed, updated docs
</commit_message>
<xml_diff>
--- a/docs/database/FedProspect-ERD.pptx
+++ b/docs/database/FedProspect-ERD.pptx
@@ -3727,6 +3727,10 @@
             </a:r>
             <a:br/>
             <a:r>
+              <a:t>ai_usage_log</a:t>
+            </a:r>
+            <a:br/>
+            <a:r>
               <a:t>federal_organization</a:t>
             </a:r>
             <a:br/>
@@ -17582,8 +17586,8 @@
         </p:nvSpPr>
         <p:spPr>
           <a:xfrm>
-            <a:off x="9418320" y="1188720"/>
-            <a:ext cx="2286000" cy="320040"/>
+            <a:off x="3566160" y="4846320"/>
+            <a:ext cx="2560320" cy="320040"/>
           </a:xfrm>
           <a:prstGeom prst="roundRect">
             <a:avLst/>
@@ -17623,7 +17627,7 @@
               </a:defRPr>
             </a:pPr>
             <a:r>
-              <a:t>stg_entity_raw</a:t>
+              <a:t>ai_usage_log</a:t>
             </a:r>
           </a:p>
         </p:txBody>
@@ -17636,8 +17640,8 @@
         </p:nvSpPr>
         <p:spPr>
           <a:xfrm>
-            <a:off x="9418320" y="1508760"/>
-            <a:ext cx="2286000" cy="1508760"/>
+            <a:off x="3566160" y="5166360"/>
+            <a:ext cx="2560320" cy="1143000"/>
           </a:xfrm>
           <a:prstGeom prst="rect">
             <a:avLst/>
@@ -17683,6 +17687,246 @@
               </a:defRPr>
             </a:pPr>
             <a:r>
+              <a:t>PK usage_id INT AUTO_INCREMENT</a:t>
+            </a:r>
+          </a:p>
+          <a:p>
+            <a:pPr>
+              <a:spcBef>
+                <a:spcPts val="0"/>
+              </a:spcBef>
+              <a:spcAft>
+                <a:spcPts val="100"/>
+              </a:spcAft>
+              <a:defRPr sz="800">
+                <a:solidFill>
+                  <a:srgbClr val="000000"/>
+                </a:solidFill>
+              </a:defRPr>
+            </a:pPr>
+            <a:r>
+              <a:t>   notice_id VARCHAR(100)</a:t>
+            </a:r>
+          </a:p>
+          <a:p>
+            <a:pPr>
+              <a:spcBef>
+                <a:spcPts val="0"/>
+              </a:spcBef>
+              <a:spcAft>
+                <a:spcPts val="100"/>
+              </a:spcAft>
+              <a:defRPr sz="800">
+                <a:solidFill>
+                  <a:srgbClr val="000000"/>
+                </a:solidFill>
+              </a:defRPr>
+            </a:pPr>
+            <a:r>
+              <a:t>   attachment_id INT</a:t>
+            </a:r>
+          </a:p>
+          <a:p>
+            <a:pPr>
+              <a:spcBef>
+                <a:spcPts val="0"/>
+              </a:spcBef>
+              <a:spcAft>
+                <a:spcPts val="100"/>
+              </a:spcAft>
+              <a:defRPr sz="800">
+                <a:solidFill>
+                  <a:srgbClr val="000000"/>
+                </a:solidFill>
+              </a:defRPr>
+            </a:pPr>
+            <a:r>
+              <a:t>   model VARCHAR(50)</a:t>
+            </a:r>
+          </a:p>
+          <a:p>
+            <a:pPr>
+              <a:spcBef>
+                <a:spcPts val="0"/>
+              </a:spcBef>
+              <a:spcAft>
+                <a:spcPts val="100"/>
+              </a:spcAft>
+              <a:defRPr sz="800">
+                <a:solidFill>
+                  <a:srgbClr val="000000"/>
+                </a:solidFill>
+              </a:defRPr>
+            </a:pPr>
+            <a:r>
+              <a:t>   input_tokens / output_tokens</a:t>
+            </a:r>
+          </a:p>
+          <a:p>
+            <a:pPr>
+              <a:spcBef>
+                <a:spcPts val="0"/>
+              </a:spcBef>
+              <a:spcAft>
+                <a:spcPts val="100"/>
+              </a:spcAft>
+              <a:defRPr sz="800">
+                <a:solidFill>
+                  <a:srgbClr val="000000"/>
+                </a:solidFill>
+              </a:defRPr>
+            </a:pPr>
+            <a:r>
+              <a:t>   cache_read / cache_write tokens</a:t>
+            </a:r>
+          </a:p>
+          <a:p>
+            <a:pPr>
+              <a:spcBef>
+                <a:spcPts val="0"/>
+              </a:spcBef>
+              <a:spcAft>
+                <a:spcPts val="100"/>
+              </a:spcAft>
+              <a:defRPr sz="800">
+                <a:solidFill>
+                  <a:srgbClr val="000000"/>
+                </a:solidFill>
+              </a:defRPr>
+            </a:pPr>
+            <a:r>
+              <a:t>   cost_usd DECIMAL(10,6)</a:t>
+            </a:r>
+          </a:p>
+          <a:p>
+            <a:pPr>
+              <a:spcBef>
+                <a:spcPts val="0"/>
+              </a:spcBef>
+              <a:spcAft>
+                <a:spcPts val="100"/>
+              </a:spcAft>
+              <a:defRPr sz="800">
+                <a:solidFill>
+                  <a:srgbClr val="000000"/>
+                </a:solidFill>
+              </a:defRPr>
+            </a:pPr>
+            <a:r>
+              <a:t>   requested_by INT</a:t>
+            </a:r>
+          </a:p>
+        </p:txBody>
+      </p:sp>
+      <p:sp>
+        <p:nvSpPr>
+          <p:cNvPr id="23" name="Rounded Rectangle 22"/>
+          <p:cNvSpPr/>
+          <p:nvPr/>
+        </p:nvSpPr>
+        <p:spPr>
+          <a:xfrm>
+            <a:off x="9418320" y="1188720"/>
+            <a:ext cx="2286000" cy="320040"/>
+          </a:xfrm>
+          <a:prstGeom prst="roundRect">
+            <a:avLst/>
+          </a:prstGeom>
+          <a:solidFill>
+            <a:srgbClr val="616161"/>
+          </a:solidFill>
+          <a:ln w="12700">
+            <a:solidFill>
+              <a:srgbClr val="616161"/>
+            </a:solidFill>
+          </a:ln>
+        </p:spPr>
+        <p:style>
+          <a:lnRef idx="1">
+            <a:schemeClr val="accent1"/>
+          </a:lnRef>
+          <a:fillRef idx="3">
+            <a:schemeClr val="accent1"/>
+          </a:fillRef>
+          <a:effectRef idx="2">
+            <a:schemeClr val="accent1"/>
+          </a:effectRef>
+          <a:fontRef idx="minor">
+            <a:schemeClr val="lt1"/>
+          </a:fontRef>
+        </p:style>
+        <p:txBody>
+          <a:bodyPr rtlCol="0" anchor="ctr" wrap="square" lIns="73152" rIns="73152" tIns="18288" bIns="18288"/>
+          <a:lstStyle/>
+          <a:p>
+            <a:pPr algn="ctr">
+              <a:defRPr sz="1000" b="1">
+                <a:solidFill>
+                  <a:srgbClr val="FFFFFF"/>
+                </a:solidFill>
+              </a:defRPr>
+            </a:pPr>
+            <a:r>
+              <a:t>stg_entity_raw</a:t>
+            </a:r>
+          </a:p>
+        </p:txBody>
+      </p:sp>
+      <p:sp>
+        <p:nvSpPr>
+          <p:cNvPr id="24" name="Rectangle 23"/>
+          <p:cNvSpPr/>
+          <p:nvPr/>
+        </p:nvSpPr>
+        <p:spPr>
+          <a:xfrm>
+            <a:off x="9418320" y="1508760"/>
+            <a:ext cx="2286000" cy="1508760"/>
+          </a:xfrm>
+          <a:prstGeom prst="rect">
+            <a:avLst/>
+          </a:prstGeom>
+          <a:solidFill>
+            <a:srgbClr val="E0E0E0"/>
+          </a:solidFill>
+          <a:ln w="12700">
+            <a:solidFill>
+              <a:srgbClr val="616161"/>
+            </a:solidFill>
+          </a:ln>
+        </p:spPr>
+        <p:style>
+          <a:lnRef idx="1">
+            <a:schemeClr val="accent1"/>
+          </a:lnRef>
+          <a:fillRef idx="3">
+            <a:schemeClr val="accent1"/>
+          </a:fillRef>
+          <a:effectRef idx="2">
+            <a:schemeClr val="accent1"/>
+          </a:effectRef>
+          <a:fontRef idx="minor">
+            <a:schemeClr val="lt1"/>
+          </a:fontRef>
+        </p:style>
+        <p:txBody>
+          <a:bodyPr rtlCol="0" anchor="ctr" wrap="square" lIns="73152" rIns="73152" tIns="36576" bIns="36576"/>
+          <a:lstStyle/>
+          <a:p>
+            <a:pPr algn="ctr">
+              <a:spcBef>
+                <a:spcPts val="0"/>
+              </a:spcBef>
+              <a:spcAft>
+                <a:spcPts val="100"/>
+              </a:spcAft>
+              <a:defRPr sz="800" b="1">
+                <a:solidFill>
+                  <a:srgbClr val="000000"/>
+                </a:solidFill>
+              </a:defRPr>
+            </a:pPr>
+            <a:r>
               <a:t>PK load_id INT</a:t>
             </a:r>
           </a:p>
@@ -17798,7 +18042,7 @@
       </p:sp>
       <p:sp>
         <p:nvSpPr>
-          <p:cNvPr id="23" name="TextBox 22"/>
+          <p:cNvPr id="25" name="TextBox 24"/>
           <p:cNvSpPr txBox="1"/>
           <p:nvPr/>
         </p:nvSpPr>

</xml_diff>